<commit_message>
Match SIH official presentation palette
</commit_message>
<xml_diff>
--- a/deliverables/SakshiAstra_reviewed.pptx
+++ b/deliverables/SakshiAstra_reviewed.pptx
@@ -13376,7 +13376,7 @@
             </a:pPr>
             <a:endParaRPr sz="1800" cap="none">
               <a:solidFill>
-                <a:srgbClr val="953734"/>
+                <a:srgbClr val="C0504D"/>
               </a:solidFill>
               <a:latin typeface="Calibri" pitchFamily="2" charset="0"/>
               <a:ea typeface="Calibri" pitchFamily="2" charset="0"/>
@@ -13720,7 +13720,7 @@
             <a:pPr>
               <a:defRPr sz="1800" b="1" cap="none">
                 <a:solidFill>
-                  <a:srgbClr val="173754"/>
+                  <a:srgbClr val="1F497D"/>
                 </a:solidFill>
               </a:defRPr>
             </a:pPr>
@@ -13763,7 +13763,7 @@
             <a:pPr>
               <a:defRPr sz="1600" b="1" cap="none">
                 <a:solidFill>
-                  <a:srgbClr val="173754"/>
+                  <a:srgbClr val="1F497D"/>
                 </a:solidFill>
               </a:defRPr>
             </a:pPr>
@@ -13796,7 +13796,7 @@
           <a:noFill/>
           <a:ln w="12700" cap="flat" cmpd="sng" algn="ctr">
             <a:solidFill>
-              <a:srgbClr val="CFDDE6"/>
+              <a:srgbClr val="4F81BD"/>
             </a:solidFill>
             <a:prstDash val="solid"/>
             <a:headEnd type="none"/>
@@ -13838,7 +13838,7 @@
             <a:pPr>
               <a:defRPr sz="1500" cap="none">
                 <a:solidFill>
-                  <a:srgbClr val="172B3A"/>
+                  <a:srgbClr val="000000"/>
                 </a:solidFill>
               </a:defRPr>
             </a:pPr>
@@ -13881,7 +13881,7 @@
             <a:pPr>
               <a:defRPr sz="1600" b="1" cap="none">
                 <a:solidFill>
-                  <a:srgbClr val="173754"/>
+                  <a:srgbClr val="1F497D"/>
                 </a:solidFill>
               </a:defRPr>
             </a:pPr>
@@ -13924,7 +13924,7 @@
             <a:pPr>
               <a:defRPr sz="1450" cap="none">
                 <a:solidFill>
-                  <a:srgbClr val="172B3A"/>
+                  <a:srgbClr val="000000"/>
                 </a:solidFill>
               </a:defRPr>
             </a:pPr>
@@ -13957,7 +13957,7 @@
           <a:noFill/>
           <a:ln w="12700" cap="flat" cmpd="sng" algn="ctr">
             <a:solidFill>
-              <a:srgbClr val="CFDDE6"/>
+              <a:srgbClr val="4F81BD"/>
             </a:solidFill>
             <a:prstDash val="solid"/>
             <a:headEnd type="none"/>
@@ -13999,7 +13999,7 @@
             <a:pPr>
               <a:defRPr sz="1750" b="1" cap="none">
                 <a:solidFill>
-                  <a:srgbClr val="0073B9"/>
+                  <a:srgbClr val="0070C0"/>
                 </a:solidFill>
               </a:defRPr>
             </a:pPr>
@@ -14042,7 +14042,7 @@
             <a:pPr>
               <a:defRPr sz="1500" b="1" cap="none">
                 <a:solidFill>
-                  <a:srgbClr val="173754"/>
+                  <a:srgbClr val="1F497D"/>
                 </a:solidFill>
               </a:defRPr>
             </a:pPr>
@@ -14085,7 +14085,7 @@
             <a:pPr>
               <a:defRPr sz="1600" b="1" cap="none">
                 <a:solidFill>
-                  <a:srgbClr val="173754"/>
+                  <a:srgbClr val="1F497D"/>
                 </a:solidFill>
               </a:defRPr>
             </a:pPr>
@@ -14128,7 +14128,7 @@
             <a:pPr>
               <a:defRPr cap="none">
                 <a:solidFill>
-                  <a:srgbClr val="172B3A"/>
+                  <a:srgbClr val="000000"/>
                 </a:solidFill>
               </a:defRPr>
             </a:pPr>
@@ -14171,7 +14171,7 @@
             <a:pPr>
               <a:defRPr sz="1600" b="1" cap="none">
                 <a:solidFill>
-                  <a:srgbClr val="173754"/>
+                  <a:srgbClr val="1F497D"/>
                 </a:solidFill>
               </a:defRPr>
             </a:pPr>
@@ -14214,7 +14214,7 @@
             <a:pPr>
               <a:defRPr cap="none">
                 <a:solidFill>
-                  <a:srgbClr val="172B3A"/>
+                  <a:srgbClr val="000000"/>
                 </a:solidFill>
               </a:defRPr>
             </a:pPr>
@@ -14257,7 +14257,7 @@
             <a:pPr>
               <a:defRPr sz="1600" b="1" cap="none">
                 <a:solidFill>
-                  <a:srgbClr val="173754"/>
+                  <a:srgbClr val="1F497D"/>
                 </a:solidFill>
               </a:defRPr>
             </a:pPr>
@@ -14300,7 +14300,7 @@
             <a:pPr>
               <a:defRPr cap="none">
                 <a:solidFill>
-                  <a:srgbClr val="172B3A"/>
+                  <a:srgbClr val="000000"/>
                 </a:solidFill>
               </a:defRPr>
             </a:pPr>
@@ -14343,7 +14343,7 @@
             <a:pPr>
               <a:defRPr sz="1600" b="1" cap="none">
                 <a:solidFill>
-                  <a:srgbClr val="173754"/>
+                  <a:srgbClr val="1F497D"/>
                 </a:solidFill>
               </a:defRPr>
             </a:pPr>
@@ -14386,7 +14386,7 @@
             <a:pPr>
               <a:defRPr cap="none">
                 <a:solidFill>
-                  <a:srgbClr val="172B3A"/>
+                  <a:srgbClr val="000000"/>
                 </a:solidFill>
               </a:defRPr>
             </a:pPr>
@@ -14472,7 +14472,7 @@
             <a:pPr>
               <a:defRPr cap="none">
                 <a:solidFill>
-                  <a:srgbClr val="172B3A"/>
+                  <a:srgbClr val="000000"/>
                 </a:solidFill>
               </a:defRPr>
             </a:pPr>
@@ -14515,7 +14515,7 @@
             <a:pPr>
               <a:defRPr sz="1600" b="1" cap="none">
                 <a:solidFill>
-                  <a:srgbClr val="087F8C"/>
+                  <a:srgbClr val="4BACC6"/>
                 </a:solidFill>
               </a:defRPr>
             </a:pPr>
@@ -14568,11 +14568,11 @@
               </a:avLst>
             </a:prstGeom>
             <a:solidFill>
-              <a:srgbClr val="EEF5F9"/>
+              <a:srgbClr val="DCE6F2"/>
             </a:solidFill>
             <a:ln w="12700" cap="flat" cmpd="sng" algn="ctr">
               <a:solidFill>
-                <a:srgbClr val="CFDDE6"/>
+                <a:srgbClr val="4F81BD"/>
               </a:solidFill>
               <a:prstDash val="solid"/>
               <a:headEnd type="none"/>
@@ -14618,7 +14618,7 @@
               <a:avLst/>
             </a:prstGeom>
             <a:solidFill>
-              <a:srgbClr val="173754"/>
+              <a:srgbClr val="1F497D"/>
             </a:solidFill>
             <a:ln>
               <a:noFill/>
@@ -14681,14 +14681,14 @@
               <a:r>
                 <a:rPr b="1" cap="none">
                   <a:solidFill>
-                    <a:srgbClr val="173754"/>
+                    <a:srgbClr val="1F497D"/>
                   </a:solidFill>
                 </a:rPr>
                 <a:t>Collect</a:t>
               </a:r>
               <a:endParaRPr b="1" cap="none">
                 <a:solidFill>
-                  <a:srgbClr val="173754"/>
+                  <a:srgbClr val="1F497D"/>
                 </a:solidFill>
               </a:endParaRPr>
             </a:p>
@@ -14728,14 +14728,14 @@
               <a:r>
                 <a:rPr sz="1050" cap="none">
                   <a:solidFill>
-                    <a:srgbClr val="506473"/>
+                    <a:srgbClr val="808080"/>
                   </a:solidFill>
                 </a:rPr>
                 <a:t>Tor markets &amp; forums, hashed snapshots</a:t>
               </a:r>
               <a:endParaRPr sz="1050" cap="none">
                 <a:solidFill>
-                  <a:srgbClr val="506473"/>
+                  <a:srgbClr val="808080"/>
                 </a:solidFill>
               </a:endParaRPr>
             </a:p>
@@ -14764,7 +14764,7 @@
               </a:avLst>
             </a:prstGeom>
             <a:solidFill>
-              <a:srgbClr val="173754"/>
+              <a:srgbClr val="1F497D"/>
             </a:solidFill>
             <a:ln>
               <a:noFill/>
@@ -14811,11 +14811,11 @@
               </a:avLst>
             </a:prstGeom>
             <a:solidFill>
-              <a:srgbClr val="EEF5F9"/>
+              <a:srgbClr val="DCE6F2"/>
             </a:solidFill>
             <a:ln w="12700" cap="flat" cmpd="sng" algn="ctr">
               <a:solidFill>
-                <a:srgbClr val="CFDDE6"/>
+                <a:srgbClr val="4F81BD"/>
               </a:solidFill>
               <a:prstDash val="solid"/>
               <a:headEnd type="none"/>
@@ -14861,7 +14861,7 @@
               <a:avLst/>
             </a:prstGeom>
             <a:solidFill>
-              <a:srgbClr val="173754"/>
+              <a:srgbClr val="1F497D"/>
             </a:solidFill>
             <a:ln>
               <a:noFill/>
@@ -14924,14 +14924,14 @@
               <a:r>
                 <a:rPr b="1" cap="none">
                   <a:solidFill>
-                    <a:srgbClr val="173754"/>
+                    <a:srgbClr val="1F497D"/>
                   </a:solidFill>
                 </a:rPr>
                 <a:t>Link</a:t>
               </a:r>
               <a:endParaRPr b="1" cap="none">
                 <a:solidFill>
-                  <a:srgbClr val="173754"/>
+                  <a:srgbClr val="1F497D"/>
                 </a:solidFill>
               </a:endParaRPr>
             </a:p>
@@ -14971,14 +14971,14 @@
               <a:r>
                 <a:rPr sz="1050" cap="none">
                   <a:solidFill>
-                    <a:srgbClr val="506473"/>
+                    <a:srgbClr val="808080"/>
                   </a:solidFill>
                 </a:rPr>
                 <a:t>Personas, PGP keys, crypto wallets, servers</a:t>
               </a:r>
               <a:endParaRPr sz="1050" cap="none">
                 <a:solidFill>
-                  <a:srgbClr val="506473"/>
+                  <a:srgbClr val="808080"/>
                 </a:solidFill>
               </a:endParaRPr>
             </a:p>
@@ -15007,7 +15007,7 @@
               </a:avLst>
             </a:prstGeom>
             <a:solidFill>
-              <a:srgbClr val="173754"/>
+              <a:srgbClr val="1F497D"/>
             </a:solidFill>
             <a:ln>
               <a:noFill/>
@@ -15054,11 +15054,11 @@
               </a:avLst>
             </a:prstGeom>
             <a:solidFill>
-              <a:srgbClr val="EEF5F9"/>
+              <a:srgbClr val="DCE6F2"/>
             </a:solidFill>
             <a:ln w="12700" cap="flat" cmpd="sng" algn="ctr">
               <a:solidFill>
-                <a:srgbClr val="CFDDE6"/>
+                <a:srgbClr val="4F81BD"/>
               </a:solidFill>
               <a:prstDash val="solid"/>
               <a:headEnd type="none"/>
@@ -15104,7 +15104,7 @@
               <a:avLst/>
             </a:prstGeom>
             <a:solidFill>
-              <a:srgbClr val="173754"/>
+              <a:srgbClr val="1F497D"/>
             </a:solidFill>
             <a:ln>
               <a:noFill/>
@@ -15167,14 +15167,14 @@
               <a:r>
                 <a:rPr b="1" cap="none">
                   <a:solidFill>
-                    <a:srgbClr val="173754"/>
+                    <a:srgbClr val="1F497D"/>
                   </a:solidFill>
                 </a:rPr>
                 <a:t>Verify</a:t>
               </a:r>
               <a:endParaRPr b="1" cap="none">
                 <a:solidFill>
-                  <a:srgbClr val="173754"/>
+                  <a:srgbClr val="1F497D"/>
                 </a:solidFill>
               </a:endParaRPr>
             </a:p>
@@ -15214,14 +15214,14 @@
               <a:r>
                 <a:rPr sz="1050" cap="none">
                   <a:solidFill>
-                    <a:srgbClr val="506473"/>
+                    <a:srgbClr val="808080"/>
                   </a:solidFill>
                 </a:rPr>
                 <a:t>Each claim scored by how hard it is to fake</a:t>
               </a:r>
               <a:endParaRPr sz="1050" cap="none">
                 <a:solidFill>
-                  <a:srgbClr val="506473"/>
+                  <a:srgbClr val="808080"/>
                 </a:solidFill>
               </a:endParaRPr>
             </a:p>
@@ -15250,7 +15250,7 @@
               </a:avLst>
             </a:prstGeom>
             <a:solidFill>
-              <a:srgbClr val="173754"/>
+              <a:srgbClr val="1F497D"/>
             </a:solidFill>
             <a:ln>
               <a:noFill/>
@@ -15297,11 +15297,11 @@
               </a:avLst>
             </a:prstGeom>
             <a:solidFill>
-              <a:srgbClr val="173754"/>
+              <a:srgbClr val="1F497D"/>
             </a:solidFill>
             <a:ln w="12700" cap="flat" cmpd="sng" algn="ctr">
               <a:solidFill>
-                <a:srgbClr val="173754"/>
+                <a:srgbClr val="1F497D"/>
               </a:solidFill>
               <a:prstDash val="solid"/>
               <a:headEnd type="none"/>
@@ -15457,14 +15457,14 @@
               <a:r>
                 <a:rPr sz="1050" cap="none">
                   <a:solidFill>
-                    <a:srgbClr val="DCE6EE"/>
+                    <a:srgbClr val="DCE6F2"/>
                   </a:solidFill>
                 </a:rPr>
                 <a:t>ASSERT, HOLD or REJECT each claim</a:t>
               </a:r>
               <a:endParaRPr sz="1050" cap="none">
                 <a:solidFill>
-                  <a:srgbClr val="DCE6EE"/>
+                  <a:srgbClr val="DCE6F2"/>
                 </a:solidFill>
               </a:endParaRPr>
             </a:p>
@@ -15552,7 +15552,7 @@
             </a:pPr>
             <a:endParaRPr sz="1800" cap="none">
               <a:solidFill>
-                <a:srgbClr val="953734"/>
+                <a:srgbClr val="C0504D"/>
               </a:solidFill>
               <a:latin typeface="Calibri" pitchFamily="2" charset="0"/>
               <a:ea typeface="Calibri" pitchFamily="2" charset="0"/>
@@ -15842,7 +15842,7 @@
           <a:noFill/>
           <a:ln w="17145" cap="flat" cmpd="sng" algn="ctr">
             <a:solidFill>
-              <a:srgbClr val="0073B9"/>
+              <a:srgbClr val="0070C0"/>
             </a:solidFill>
             <a:prstDash val="solid"/>
             <a:headEnd type="none"/>
@@ -15879,7 +15879,7 @@
           <a:noFill/>
           <a:ln w="17145" cap="flat" cmpd="sng" algn="ctr">
             <a:solidFill>
-              <a:srgbClr val="0073B9"/>
+              <a:srgbClr val="0070C0"/>
             </a:solidFill>
             <a:prstDash val="solid"/>
             <a:headEnd type="none"/>
@@ -15916,7 +15916,7 @@
           <a:noFill/>
           <a:ln w="17145" cap="flat" cmpd="sng" algn="ctr">
             <a:solidFill>
-              <a:srgbClr val="0073B9"/>
+              <a:srgbClr val="0070C0"/>
             </a:solidFill>
             <a:prstDash val="solid"/>
             <a:headEnd type="none"/>
@@ -15950,7 +15950,7 @@
           <a:noFill/>
           <a:ln w="17145" cap="flat" cmpd="sng" algn="ctr">
             <a:solidFill>
-              <a:srgbClr val="0073B9"/>
+              <a:srgbClr val="0070C0"/>
             </a:solidFill>
             <a:prstDash val="solid"/>
             <a:headEnd type="none"/>
@@ -15987,7 +15987,7 @@
           <a:noFill/>
           <a:ln w="17145" cap="flat" cmpd="sng" algn="ctr">
             <a:solidFill>
-              <a:srgbClr val="0073B9"/>
+              <a:srgbClr val="0070C0"/>
             </a:solidFill>
             <a:prstDash val="solid"/>
             <a:headEnd type="none"/>
@@ -16024,7 +16024,7 @@
           <a:noFill/>
           <a:ln w="17145" cap="flat" cmpd="sng" algn="ctr">
             <a:solidFill>
-              <a:srgbClr val="0073B9"/>
+              <a:srgbClr val="0070C0"/>
             </a:solidFill>
             <a:prstDash val="solid"/>
             <a:headEnd type="none"/>
@@ -16061,7 +16061,7 @@
           <a:noFill/>
           <a:ln w="17145" cap="flat" cmpd="sng" algn="ctr">
             <a:solidFill>
-              <a:srgbClr val="0073B9"/>
+              <a:srgbClr val="0070C0"/>
             </a:solidFill>
             <a:prstDash val="solid"/>
             <a:headEnd type="none"/>
@@ -16098,7 +16098,7 @@
           <a:noFill/>
           <a:ln w="17145" cap="flat" cmpd="sng" algn="ctr">
             <a:solidFill>
-              <a:srgbClr val="0073B9"/>
+              <a:srgbClr val="0070C0"/>
             </a:solidFill>
             <a:prstDash val="solid"/>
             <a:headEnd type="none"/>
@@ -16132,7 +16132,7 @@
           <a:noFill/>
           <a:ln w="17145" cap="flat" cmpd="sng" algn="ctr">
             <a:solidFill>
-              <a:srgbClr val="0073B9"/>
+              <a:srgbClr val="0070C0"/>
             </a:solidFill>
             <a:prstDash val="solid"/>
             <a:headEnd type="none"/>
@@ -16166,7 +16166,7 @@
           <a:noFill/>
           <a:ln w="17145" cap="flat" cmpd="sng" algn="ctr">
             <a:solidFill>
-              <a:srgbClr val="0073B9"/>
+              <a:srgbClr val="0070C0"/>
             </a:solidFill>
             <a:prstDash val="solid"/>
             <a:headEnd type="none"/>
@@ -16208,7 +16208,7 @@
             <a:pPr>
               <a:defRPr sz="1800" b="1" cap="none">
                 <a:solidFill>
-                  <a:srgbClr val="173754"/>
+                  <a:srgbClr val="1F497D"/>
                 </a:solidFill>
               </a:defRPr>
             </a:pPr>
@@ -16241,11 +16241,11 @@
             </a:avLst>
           </a:prstGeom>
           <a:solidFill>
-            <a:srgbClr val="EEF5F9"/>
+            <a:srgbClr val="DCE6F2"/>
           </a:solidFill>
           <a:ln w="12700" cap="flat" cmpd="sng" algn="ctr">
             <a:solidFill>
-              <a:srgbClr val="CFDDE6"/>
+              <a:srgbClr val="4F81BD"/>
             </a:solidFill>
             <a:prstDash val="dash"/>
             <a:headEnd type="none"/>
@@ -16287,7 +16287,7 @@
             <a:pPr>
               <a:defRPr b="1" cap="none">
                 <a:solidFill>
-                  <a:srgbClr val="173754"/>
+                  <a:srgbClr val="1F497D"/>
                 </a:solidFill>
               </a:defRPr>
             </a:pPr>
@@ -16330,7 +16330,7 @@
             <a:pPr>
               <a:defRPr sz="1100" cap="none">
                 <a:solidFill>
-                  <a:srgbClr val="506473"/>
+                  <a:srgbClr val="808080"/>
                 </a:solidFill>
               </a:defRPr>
             </a:pPr>
@@ -16342,7 +16342,7 @@
             <a:pPr>
               <a:defRPr sz="1200" cap="none">
                 <a:solidFill>
-                  <a:srgbClr val="506473"/>
+                  <a:srgbClr val="808080"/>
                 </a:solidFill>
               </a:defRPr>
             </a:pPr>
@@ -16354,7 +16354,7 @@
             <a:pPr>
               <a:defRPr sz="800" i="1" cap="none">
                 <a:solidFill>
-                  <a:srgbClr val="7B93A6"/>
+                  <a:srgbClr val="808080"/>
                 </a:solidFill>
               </a:defRPr>
             </a:pPr>
@@ -16387,11 +16387,11 @@
             </a:avLst>
           </a:prstGeom>
           <a:solidFill>
-            <a:srgbClr val="EEF5F9"/>
+            <a:srgbClr val="DCE6F2"/>
           </a:solidFill>
           <a:ln w="12700" cap="flat" cmpd="sng" algn="ctr">
             <a:solidFill>
-              <a:srgbClr val="CFDDE6"/>
+              <a:srgbClr val="4F81BD"/>
             </a:solidFill>
             <a:prstDash val="dash"/>
             <a:headEnd type="none"/>
@@ -16433,7 +16433,7 @@
             <a:pPr>
               <a:defRPr b="1" cap="none">
                 <a:solidFill>
-                  <a:srgbClr val="173754"/>
+                  <a:srgbClr val="1F497D"/>
                 </a:solidFill>
               </a:defRPr>
             </a:pPr>
@@ -16476,7 +16476,7 @@
             <a:pPr>
               <a:defRPr sz="1200" cap="none">
                 <a:solidFill>
-                  <a:srgbClr val="506473"/>
+                  <a:srgbClr val="808080"/>
                 </a:solidFill>
               </a:defRPr>
             </a:pPr>
@@ -16488,7 +16488,7 @@
             <a:pPr>
               <a:defRPr sz="1200" cap="none">
                 <a:solidFill>
-                  <a:srgbClr val="506473"/>
+                  <a:srgbClr val="808080"/>
                 </a:solidFill>
               </a:defRPr>
             </a:pPr>
@@ -16500,7 +16500,7 @@
             <a:pPr>
               <a:defRPr sz="800" i="1" cap="none">
                 <a:solidFill>
-                  <a:srgbClr val="7B93A6"/>
+                  <a:srgbClr val="808080"/>
                 </a:solidFill>
               </a:defRPr>
             </a:pPr>
@@ -16533,11 +16533,11 @@
             </a:avLst>
           </a:prstGeom>
           <a:solidFill>
-            <a:srgbClr val="EEF5F9"/>
+            <a:srgbClr val="DCE6F2"/>
           </a:solidFill>
           <a:ln w="12700" cap="flat" cmpd="sng" algn="ctr">
             <a:solidFill>
-              <a:srgbClr val="CFDDE6"/>
+              <a:srgbClr val="4F81BD"/>
             </a:solidFill>
             <a:prstDash val="solid"/>
             <a:headEnd type="none"/>
@@ -16579,7 +16579,7 @@
             <a:pPr>
               <a:defRPr b="1" cap="none">
                 <a:solidFill>
-                  <a:srgbClr val="173754"/>
+                  <a:srgbClr val="1F497D"/>
                 </a:solidFill>
               </a:defRPr>
             </a:pPr>
@@ -16622,7 +16622,7 @@
             <a:pPr>
               <a:defRPr sz="1200" cap="none">
                 <a:solidFill>
-                  <a:srgbClr val="506473"/>
+                  <a:srgbClr val="808080"/>
                 </a:solidFill>
               </a:defRPr>
             </a:pPr>
@@ -16634,7 +16634,7 @@
             <a:pPr>
               <a:defRPr sz="1200" cap="none">
                 <a:solidFill>
-                  <a:srgbClr val="506473"/>
+                  <a:srgbClr val="808080"/>
                 </a:solidFill>
               </a:defRPr>
             </a:pPr>
@@ -16646,7 +16646,7 @@
             <a:pPr>
               <a:defRPr sz="800" i="1" cap="none">
                 <a:solidFill>
-                  <a:srgbClr val="7B93A6"/>
+                  <a:srgbClr val="808080"/>
                 </a:solidFill>
               </a:defRPr>
             </a:pPr>
@@ -16679,11 +16679,11 @@
             </a:avLst>
           </a:prstGeom>
           <a:solidFill>
-            <a:srgbClr val="EEF5F9"/>
+            <a:srgbClr val="DCE6F2"/>
           </a:solidFill>
           <a:ln w="12700" cap="flat" cmpd="sng" algn="ctr">
             <a:solidFill>
-              <a:srgbClr val="CFDDE6"/>
+              <a:srgbClr val="4F81BD"/>
             </a:solidFill>
             <a:prstDash val="dash"/>
             <a:headEnd type="none"/>
@@ -16725,7 +16725,7 @@
             <a:pPr>
               <a:defRPr b="1" cap="none">
                 <a:solidFill>
-                  <a:srgbClr val="173754"/>
+                  <a:srgbClr val="1F497D"/>
                 </a:solidFill>
               </a:defRPr>
             </a:pPr>
@@ -16768,7 +16768,7 @@
             <a:pPr>
               <a:defRPr sz="1200" cap="none">
                 <a:solidFill>
-                  <a:srgbClr val="506473"/>
+                  <a:srgbClr val="808080"/>
                 </a:solidFill>
               </a:defRPr>
             </a:pPr>
@@ -16780,7 +16780,7 @@
             <a:pPr>
               <a:defRPr sz="1200" cap="none">
                 <a:solidFill>
-                  <a:srgbClr val="506473"/>
+                  <a:srgbClr val="808080"/>
                 </a:solidFill>
               </a:defRPr>
             </a:pPr>
@@ -16792,7 +16792,7 @@
             <a:pPr>
               <a:defRPr sz="800" i="1" cap="none">
                 <a:solidFill>
-                  <a:srgbClr val="7B93A6"/>
+                  <a:srgbClr val="808080"/>
                 </a:solidFill>
               </a:defRPr>
             </a:pPr>
@@ -16825,11 +16825,11 @@
             </a:avLst>
           </a:prstGeom>
           <a:solidFill>
-            <a:srgbClr val="EEF5F9"/>
+            <a:srgbClr val="DCE6F2"/>
           </a:solidFill>
           <a:ln w="12700" cap="flat" cmpd="sng" algn="ctr">
             <a:solidFill>
-              <a:srgbClr val="CFDDE6"/>
+              <a:srgbClr val="4F81BD"/>
             </a:solidFill>
             <a:prstDash val="dash"/>
             <a:headEnd type="none"/>
@@ -16871,7 +16871,7 @@
             <a:pPr>
               <a:defRPr b="1" cap="none">
                 <a:solidFill>
-                  <a:srgbClr val="173754"/>
+                  <a:srgbClr val="1F497D"/>
                 </a:solidFill>
               </a:defRPr>
             </a:pPr>
@@ -16914,7 +16914,7 @@
             <a:pPr>
               <a:defRPr sz="1200" cap="none">
                 <a:solidFill>
-                  <a:srgbClr val="506473"/>
+                  <a:srgbClr val="808080"/>
                 </a:solidFill>
               </a:defRPr>
             </a:pPr>
@@ -16926,7 +16926,7 @@
             <a:pPr>
               <a:defRPr sz="1050" cap="none">
                 <a:solidFill>
-                  <a:srgbClr val="506473"/>
+                  <a:srgbClr val="808080"/>
                 </a:solidFill>
               </a:defRPr>
             </a:pPr>
@@ -16938,7 +16938,7 @@
             <a:pPr>
               <a:defRPr sz="800" i="1" cap="none">
                 <a:solidFill>
-                  <a:srgbClr val="7B93A6"/>
+                  <a:srgbClr val="808080"/>
                 </a:solidFill>
               </a:defRPr>
             </a:pPr>
@@ -16971,11 +16971,11 @@
             </a:avLst>
           </a:prstGeom>
           <a:solidFill>
-            <a:srgbClr val="EEF5F9"/>
+            <a:srgbClr val="DCE6F2"/>
           </a:solidFill>
           <a:ln w="12700" cap="flat" cmpd="sng" algn="ctr">
             <a:solidFill>
-              <a:srgbClr val="CFDDE6"/>
+              <a:srgbClr val="4F81BD"/>
             </a:solidFill>
             <a:prstDash val="dash"/>
             <a:headEnd type="none"/>
@@ -17017,7 +17017,7 @@
             <a:pPr>
               <a:defRPr b="1" cap="none">
                 <a:solidFill>
-                  <a:srgbClr val="173754"/>
+                  <a:srgbClr val="1F497D"/>
                 </a:solidFill>
               </a:defRPr>
             </a:pPr>
@@ -17060,7 +17060,7 @@
             <a:pPr>
               <a:defRPr sz="1200" cap="none">
                 <a:solidFill>
-                  <a:srgbClr val="506473"/>
+                  <a:srgbClr val="808080"/>
                 </a:solidFill>
               </a:defRPr>
             </a:pPr>
@@ -17072,7 +17072,7 @@
             <a:pPr>
               <a:defRPr sz="1200" cap="none">
                 <a:solidFill>
-                  <a:srgbClr val="506473"/>
+                  <a:srgbClr val="808080"/>
                 </a:solidFill>
               </a:defRPr>
             </a:pPr>
@@ -17084,7 +17084,7 @@
             <a:pPr>
               <a:defRPr sz="800" i="1" cap="none">
                 <a:solidFill>
-                  <a:srgbClr val="7B93A6"/>
+                  <a:srgbClr val="808080"/>
                 </a:solidFill>
               </a:defRPr>
             </a:pPr>
@@ -17117,11 +17117,11 @@
             </a:avLst>
           </a:prstGeom>
           <a:solidFill>
-            <a:srgbClr val="173754"/>
+            <a:srgbClr val="1F497D"/>
           </a:solidFill>
           <a:ln w="12700" cap="flat" cmpd="sng" algn="ctr">
             <a:solidFill>
-              <a:srgbClr val="173754"/>
+              <a:srgbClr val="1F497D"/>
             </a:solidFill>
             <a:prstDash val="solid"/>
             <a:headEnd type="none"/>
@@ -17163,7 +17163,7 @@
             <a:pPr>
               <a:defRPr b="1" cap="none">
                 <a:solidFill>
-                  <a:srgbClr val="173754"/>
+                  <a:srgbClr val="1F497D"/>
                 </a:solidFill>
               </a:defRPr>
             </a:pPr>
@@ -17211,7 +17211,7 @@
             <a:pPr>
               <a:defRPr sz="1200" cap="none">
                 <a:solidFill>
-                  <a:srgbClr val="506473"/>
+                  <a:srgbClr val="808080"/>
                 </a:solidFill>
               </a:defRPr>
             </a:pPr>
@@ -17249,11 +17249,11 @@
             </a:avLst>
           </a:prstGeom>
           <a:solidFill>
-            <a:srgbClr val="EEF5F9"/>
+            <a:srgbClr val="DCE6F2"/>
           </a:solidFill>
           <a:ln w="12700" cap="flat" cmpd="sng" algn="ctr">
             <a:solidFill>
-              <a:srgbClr val="CFDDE6"/>
+              <a:srgbClr val="4F81BD"/>
             </a:solidFill>
             <a:prstDash val="solid"/>
             <a:headEnd type="none"/>
@@ -17295,7 +17295,7 @@
             <a:pPr>
               <a:defRPr b="1" cap="none">
                 <a:solidFill>
-                  <a:srgbClr val="173754"/>
+                  <a:srgbClr val="1F497D"/>
                 </a:solidFill>
               </a:defRPr>
             </a:pPr>
@@ -17338,7 +17338,7 @@
             <a:pPr>
               <a:defRPr sz="1200" cap="none">
                 <a:solidFill>
-                  <a:srgbClr val="506473"/>
+                  <a:srgbClr val="808080"/>
                 </a:solidFill>
               </a:defRPr>
             </a:pPr>
@@ -17350,7 +17350,7 @@
             <a:pPr>
               <a:defRPr sz="1200" cap="none">
                 <a:solidFill>
-                  <a:srgbClr val="506473"/>
+                  <a:srgbClr val="808080"/>
                 </a:solidFill>
               </a:defRPr>
             </a:pPr>
@@ -17362,7 +17362,7 @@
             <a:pPr>
               <a:defRPr sz="800" i="1" cap="none">
                 <a:solidFill>
-                  <a:srgbClr val="7B93A6"/>
+                  <a:srgbClr val="808080"/>
                 </a:solidFill>
               </a:defRPr>
             </a:pPr>
@@ -17395,11 +17395,11 @@
             </a:avLst>
           </a:prstGeom>
           <a:solidFill>
-            <a:srgbClr val="EEF5F9"/>
+            <a:srgbClr val="DCE6F2"/>
           </a:solidFill>
           <a:ln w="12700" cap="flat" cmpd="sng" algn="ctr">
             <a:solidFill>
-              <a:srgbClr val="CFDDE6"/>
+              <a:srgbClr val="4F81BD"/>
             </a:solidFill>
             <a:prstDash val="solid"/>
             <a:headEnd type="none"/>
@@ -17441,7 +17441,7 @@
             <a:pPr>
               <a:defRPr b="1" cap="none">
                 <a:solidFill>
-                  <a:srgbClr val="173754"/>
+                  <a:srgbClr val="1F497D"/>
                 </a:solidFill>
               </a:defRPr>
             </a:pPr>
@@ -17484,7 +17484,7 @@
             <a:pPr>
               <a:defRPr sz="1200" cap="none">
                 <a:solidFill>
-                  <a:srgbClr val="506473"/>
+                  <a:srgbClr val="808080"/>
                 </a:solidFill>
               </a:defRPr>
             </a:pPr>
@@ -17496,7 +17496,7 @@
             <a:pPr>
               <a:defRPr sz="1200" cap="none">
                 <a:solidFill>
-                  <a:srgbClr val="506473"/>
+                  <a:srgbClr val="808080"/>
                 </a:solidFill>
               </a:defRPr>
             </a:pPr>
@@ -17508,7 +17508,7 @@
             <a:pPr>
               <a:defRPr sz="800" i="1" cap="none">
                 <a:solidFill>
-                  <a:srgbClr val="7B93A6"/>
+                  <a:srgbClr val="808080"/>
                 </a:solidFill>
               </a:defRPr>
             </a:pPr>
@@ -17564,7 +17564,7 @@
           <a:noFill/>
           <a:ln w="16510" cap="flat" cmpd="sng" algn="ctr">
             <a:solidFill>
-              <a:srgbClr val="087F8C"/>
+              <a:srgbClr val="4BACC6"/>
             </a:solidFill>
             <a:prstDash val="dash"/>
             <a:headEnd type="none"/>
@@ -17606,7 +17606,7 @@
             <a:pPr>
               <a:defRPr sz="1200" b="1" cap="none">
                 <a:solidFill>
-                  <a:srgbClr val="087F8C"/>
+                  <a:srgbClr val="4BACC6"/>
                 </a:solidFill>
               </a:defRPr>
             </a:pPr>
@@ -17652,7 +17652,7 @@
             <a:pPr>
               <a:defRPr sz="825" b="0">
                 <a:solidFill>
-                  <a:srgbClr val="173754"/>
+                  <a:srgbClr val="1F497D"/>
                 </a:solidFill>
                 <a:latin typeface="Arial"/>
                 <a:ea typeface="Arial"/>
@@ -17662,7 +17662,7 @@
             <a:r>
               <a:rPr sz="825" b="0">
                 <a:solidFill>
-                  <a:srgbClr val="173754"/>
+                  <a:srgbClr val="1F497D"/>
                 </a:solidFill>
                 <a:latin typeface="Arial"/>
                 <a:ea typeface="Arial"/>
@@ -17709,7 +17709,7 @@
             <a:pPr>
               <a:defRPr sz="675" b="0">
                 <a:solidFill>
-                  <a:srgbClr val="506473"/>
+                  <a:srgbClr val="808080"/>
                 </a:solidFill>
                 <a:latin typeface="Arial"/>
                 <a:ea typeface="Arial"/>
@@ -17719,7 +17719,7 @@
             <a:r>
               <a:rPr sz="675" b="0">
                 <a:solidFill>
-                  <a:srgbClr val="506473"/>
+                  <a:srgbClr val="808080"/>
                 </a:solidFill>
                 <a:latin typeface="Arial"/>
                 <a:ea typeface="Arial"/>
@@ -18188,7 +18188,7 @@
             </a:pPr>
             <a:endParaRPr sz="1800" cap="none">
               <a:solidFill>
-                <a:srgbClr val="953734"/>
+                <a:srgbClr val="C0504D"/>
               </a:solidFill>
               <a:latin typeface="Calibri" pitchFamily="2" charset="0"/>
               <a:ea typeface="Calibri" pitchFamily="2" charset="0"/>
@@ -18546,7 +18546,7 @@
             <a:pPr>
               <a:defRPr sz="1750" b="1" cap="none">
                 <a:solidFill>
-                  <a:srgbClr val="173754"/>
+                  <a:srgbClr val="1F497D"/>
                 </a:solidFill>
               </a:defRPr>
             </a:pPr>
@@ -18589,14 +18589,14 @@
             <a:pPr>
               <a:defRPr sz="1350" cap="none">
                 <a:solidFill>
-                  <a:srgbClr val="172B3A"/>
+                  <a:srgbClr val="000000"/>
                 </a:solidFill>
               </a:defRPr>
             </a:pPr>
             <a:r>
               <a:rPr sz="1350" cap="none">
                 <a:solidFill>
-                  <a:srgbClr val="172B3A"/>
+                  <a:srgbClr val="000000"/>
                 </a:solidFill>
               </a:rPr>
               <a:t>Research benchmark: locked train / validation / test protocol, 100 genuine + 210 adversarial cases, thresholds locked before testing. Working prototype: analyst workbench on fixture scenarios and Agora 2014–15 listing text. Python backend (FastAPI, DuckDB, pgpy) in development. Open-source, CPU-only.</a:t>
@@ -18637,7 +18637,7 @@
             <a:pPr>
               <a:defRPr sz="1750" b="1" cap="none">
                 <a:solidFill>
-                  <a:srgbClr val="173754"/>
+                  <a:srgbClr val="1F497D"/>
                 </a:solidFill>
               </a:defRPr>
             </a:pPr>
@@ -18708,7 +18708,7 @@
                       <a:noFill/>
                     </a:lnBlToTr>
                     <a:solidFill>
-                      <a:srgbClr val="173754"/>
+                      <a:srgbClr val="1F497D"/>
                     </a:solidFill>
                   </a:tcPr>
                 </a:tc>
@@ -18750,7 +18750,7 @@
                       <a:noFill/>
                     </a:lnBlToTr>
                     <a:solidFill>
-                      <a:srgbClr val="173754"/>
+                      <a:srgbClr val="1F497D"/>
                     </a:solidFill>
                   </a:tcPr>
                 </a:tc>
@@ -18772,7 +18772,7 @@
                       <a:r>
                         <a:rPr sz="1300" cap="none">
                           <a:solidFill>
-                            <a:srgbClr val="172B3A"/>
+                            <a:srgbClr val="000000"/>
                           </a:solidFill>
                         </a:rPr>
                         <a:t>Copied identifiers / text</a:t>
@@ -18799,7 +18799,7 @@
                       <a:noFill/>
                     </a:lnBlToTr>
                     <a:solidFill>
-                      <a:srgbClr val="F2F7FA"/>
+                      <a:srgbClr val="DCE6F2"/>
                     </a:solidFill>
                   </a:tcPr>
                 </a:tc>
@@ -18814,7 +18814,7 @@
                       <a:r>
                         <a:rPr sz="1300" cap="none">
                           <a:solidFill>
-                            <a:srgbClr val="172B3A"/>
+                            <a:srgbClr val="000000"/>
                           </a:solidFill>
                         </a:rPr>
                         <a:t>Check signed proof and replays; copied signals count only once.</a:t>
@@ -18841,7 +18841,7 @@
                       <a:noFill/>
                     </a:lnBlToTr>
                     <a:solidFill>
-                      <a:srgbClr val="F2F7FA"/>
+                      <a:srgbClr val="DCE6F2"/>
                     </a:solidFill>
                   </a:tcPr>
                 </a:tc>
@@ -18863,7 +18863,7 @@
                       <a:r>
                         <a:rPr sz="1300" cap="none">
                           <a:solidFill>
-                            <a:srgbClr val="172B3A"/>
+                            <a:srgbClr val="000000"/>
                           </a:solidFill>
                         </a:rPr>
                         <a:t>Too little evidence</a:t>
@@ -18905,7 +18905,7 @@
                       <a:r>
                         <a:rPr sz="1300" cap="none">
                           <a:solidFill>
-                            <a:srgbClr val="172B3A"/>
+                            <a:srgbClr val="000000"/>
                           </a:solidFill>
                         </a:rPr>
                         <a:t>Return HOLD instead of guessing; combine multiple independent signals.</a:t>
@@ -18954,7 +18954,7 @@
                       <a:r>
                         <a:rPr sz="1300" cap="none">
                           <a:solidFill>
-                            <a:srgbClr val="172B3A"/>
+                            <a:srgbClr val="000000"/>
                           </a:solidFill>
                         </a:rPr>
                         <a:t>Operator imitation</a:t>
@@ -18981,7 +18981,7 @@
                       <a:noFill/>
                     </a:lnBlToTr>
                     <a:solidFill>
-                      <a:srgbClr val="F2F7FA"/>
+                      <a:srgbClr val="DCE6F2"/>
                     </a:solidFill>
                   </a:tcPr>
                 </a:tc>
@@ -18996,7 +18996,7 @@
                       <a:r>
                         <a:rPr sz="1300" cap="none">
                           <a:solidFill>
-                            <a:srgbClr val="172B3A"/>
+                            <a:srgbClr val="000000"/>
                           </a:solidFill>
                         </a:rPr>
                         <a:t>Several continuity signals + independent proof + human review.</a:t>
@@ -19023,7 +19023,7 @@
                       <a:noFill/>
                     </a:lnBlToTr>
                     <a:solidFill>
-                      <a:srgbClr val="F2F7FA"/>
+                      <a:srgbClr val="DCE6F2"/>
                     </a:solidFill>
                   </a:tcPr>
                 </a:tc>
@@ -19045,7 +19045,7 @@
                       <a:r>
                         <a:rPr sz="1300" cap="none">
                           <a:solidFill>
-                            <a:srgbClr val="172B3A"/>
+                            <a:srgbClr val="000000"/>
                           </a:solidFill>
                         </a:rPr>
                         <a:t>No real-world ground truth</a:t>
@@ -19087,7 +19087,7 @@
                       <a:r>
                         <a:rPr sz="1300" cap="none">
                           <a:solidFill>
-                            <a:srgbClr val="172B3A"/>
+                            <a:srgbClr val="000000"/>
                           </a:solidFill>
                         </a:rPr>
                         <a:t>Controlled fixtures → licensed research datasets → supervised analyst pilot.</a:t>
@@ -19136,7 +19136,7 @@
                       <a:r>
                         <a:rPr sz="1300" cap="none">
                           <a:solidFill>
-                            <a:srgbClr val="172B3A"/>
+                            <a:srgbClr val="000000"/>
                           </a:solidFill>
                         </a:rPr>
                         <a:t>Legal and ethical risk</a:t>
@@ -19163,7 +19163,7 @@
                       <a:noFill/>
                     </a:lnBlToTr>
                     <a:solidFill>
-                      <a:srgbClr val="F2F7FA"/>
+                      <a:srgbClr val="DCE6F2"/>
                     </a:solidFill>
                   </a:tcPr>
                 </a:tc>
@@ -19178,7 +19178,7 @@
                       <a:r>
                         <a:rPr sz="1300" cap="none">
                           <a:solidFill>
-                            <a:srgbClr val="172B3A"/>
+                            <a:srgbClr val="000000"/>
                           </a:solidFill>
                         </a:rPr>
                         <a:t>Authorised law-enforcement use only; passive collection; human sign-off; tamper-evident audit trail; built to work within the IT Act 2000 and DPDP Act 2023.</a:t>
@@ -19205,7 +19205,7 @@
                       <a:noFill/>
                     </a:lnBlToTr>
                     <a:solidFill>
-                      <a:srgbClr val="F2F7FA"/>
+                      <a:srgbClr val="DCE6F2"/>
                     </a:solidFill>
                   </a:tcPr>
                 </a:tc>
@@ -19252,7 +19252,7 @@
             <a:pPr>
               <a:defRPr sz="1750" b="1" cap="none">
                 <a:solidFill>
-                  <a:srgbClr val="173754"/>
+                  <a:srgbClr val="1F497D"/>
                 </a:solidFill>
               </a:defRPr>
             </a:pPr>
@@ -19295,7 +19295,7 @@
             <a:pPr>
               <a:defRPr sz="1500" b="1" cap="none">
                 <a:solidFill>
-                  <a:srgbClr val="173754"/>
+                  <a:srgbClr val="1F497D"/>
                 </a:solidFill>
               </a:defRPr>
             </a:pPr>
@@ -19338,7 +19338,7 @@
             <a:pPr>
               <a:defRPr sz="1300" cap="none">
                 <a:solidFill>
-                  <a:srgbClr val="172B3A"/>
+                  <a:srgbClr val="000000"/>
                 </a:solidFill>
               </a:defRPr>
             </a:pPr>
@@ -19371,11 +19371,11 @@
             </a:avLst>
           </a:prstGeom>
           <a:solidFill>
-            <a:srgbClr val="EEF5F9"/>
+            <a:srgbClr val="DCE6F2"/>
           </a:solidFill>
           <a:ln w="12700" cap="flat" cmpd="sng" algn="ctr">
             <a:solidFill>
-              <a:srgbClr val="CFDDE6"/>
+              <a:srgbClr val="4F81BD"/>
             </a:solidFill>
             <a:prstDash val="solid"/>
             <a:headEnd type="none"/>
@@ -19400,7 +19400,7 @@
             <a:r>
               <a:rPr sz="2000" b="1" cap="none">
                 <a:solidFill>
-                  <a:srgbClr val="173754"/>
+                  <a:srgbClr val="1F497D"/>
                 </a:solidFill>
               </a:rPr>
               <a:t>0 vs 30</a:t>
@@ -19410,7 +19410,7 @@
             <a:pPr algn="ctr">
               <a:defRPr cap="none" sz="900" b="0">
                 <a:solidFill>
-                  <a:srgbClr val="506473"/>
+                  <a:srgbClr val="808080"/>
                 </a:solidFill>
                 <a:latin typeface="Arial" pitchFamily="2" charset="0"/>
                 <a:ea typeface="Arial" pitchFamily="2" charset="0"/>
@@ -19420,7 +19420,7 @@
             <a:r>
               <a:rPr sz="900" b="0" cap="none">
                 <a:solidFill>
-                  <a:srgbClr val="506473"/>
+                  <a:srgbClr val="808080"/>
                 </a:solidFill>
               </a:rPr>
               <a:t>false attributions vs. best baseline at matched recall</a:t>
@@ -19451,11 +19451,11 @@
             </a:avLst>
           </a:prstGeom>
           <a:solidFill>
-            <a:srgbClr val="EEF5F9"/>
+            <a:srgbClr val="DCE6F2"/>
           </a:solidFill>
           <a:ln w="12700" cap="flat" cmpd="sng" algn="ctr">
             <a:solidFill>
-              <a:srgbClr val="CFDDE6"/>
+              <a:srgbClr val="4F81BD"/>
             </a:solidFill>
             <a:prstDash val="solid"/>
             <a:headEnd type="none"/>
@@ -19480,7 +19480,7 @@
             <a:r>
               <a:rPr sz="2000" b="1" cap="none">
                 <a:solidFill>
-                  <a:srgbClr val="173754"/>
+                  <a:srgbClr val="1F497D"/>
                 </a:solidFill>
               </a:rPr>
               <a:t>67%</a:t>
@@ -19490,7 +19490,7 @@
             <a:pPr algn="ctr">
               <a:defRPr cap="none" sz="900" b="0">
                 <a:solidFill>
-                  <a:srgbClr val="506473"/>
+                  <a:srgbClr val="808080"/>
                 </a:solidFill>
                 <a:latin typeface="Arial" pitchFamily="2" charset="0"/>
                 <a:ea typeface="Arial" pitchFamily="2" charset="0"/>
@@ -19500,7 +19500,7 @@
             <a:r>
               <a:rPr sz="900" b="0" cap="none">
                 <a:solidFill>
-                  <a:srgbClr val="506473"/>
+                  <a:srgbClr val="808080"/>
                 </a:solidFill>
               </a:rPr>
               <a:t>of genuine migrations resolved with no false attribution</a:t>
@@ -19566,7 +19566,7 @@
             <a:pPr>
               <a:defRPr sz="750" b="0">
                 <a:solidFill>
-                  <a:srgbClr val="506473"/>
+                  <a:srgbClr val="808080"/>
                 </a:solidFill>
                 <a:latin typeface="Arial"/>
                 <a:ea typeface="Arial"/>
@@ -19576,7 +19576,7 @@
             <a:r>
               <a:rPr sz="750" b="0">
                 <a:solidFill>
-                  <a:srgbClr val="506473"/>
+                  <a:srgbClr val="808080"/>
                 </a:solidFill>
                 <a:latin typeface="Arial"/>
                 <a:ea typeface="Arial"/>
@@ -19623,7 +19623,7 @@
             <a:pPr>
               <a:defRPr sz="675" b="0">
                 <a:solidFill>
-                  <a:srgbClr val="506473"/>
+                  <a:srgbClr val="808080"/>
                 </a:solidFill>
                 <a:latin typeface="Arial"/>
                 <a:ea typeface="Arial"/>
@@ -19633,7 +19633,7 @@
             <a:r>
               <a:rPr sz="675" b="0">
                 <a:solidFill>
-                  <a:srgbClr val="506473"/>
+                  <a:srgbClr val="808080"/>
                 </a:solidFill>
                 <a:latin typeface="Arial"/>
                 <a:ea typeface="Arial"/>
@@ -19786,7 +19786,7 @@
             </a:pPr>
             <a:endParaRPr sz="1800" cap="none">
               <a:solidFill>
-                <a:srgbClr val="953734"/>
+                <a:srgbClr val="C0504D"/>
               </a:solidFill>
               <a:latin typeface="Calibri" pitchFamily="2" charset="0"/>
               <a:ea typeface="Calibri" pitchFamily="2" charset="0"/>
@@ -20136,7 +20136,7 @@
           <a:noFill/>
           <a:ln w="17145" cap="flat" cmpd="sng" algn="ctr">
             <a:solidFill>
-              <a:srgbClr val="0073B9"/>
+              <a:srgbClr val="0070C0"/>
             </a:solidFill>
             <a:prstDash val="solid"/>
             <a:headEnd type="none"/>
@@ -20178,7 +20178,7 @@
             <a:pPr>
               <a:defRPr sz="1750" b="1" cap="none">
                 <a:solidFill>
-                  <a:srgbClr val="173754"/>
+                  <a:srgbClr val="1F497D"/>
                 </a:solidFill>
               </a:defRPr>
             </a:pPr>
@@ -20211,7 +20211,7 @@
           <a:noFill/>
           <a:ln w="12700" cap="flat" cmpd="sng" algn="ctr">
             <a:solidFill>
-              <a:srgbClr val="CFDDE6"/>
+              <a:srgbClr val="4F81BD"/>
             </a:solidFill>
             <a:prstDash val="solid"/>
             <a:headEnd type="none"/>
@@ -20253,7 +20253,7 @@
             <a:pPr>
               <a:defRPr sz="1500" b="1" cap="none">
                 <a:solidFill>
-                  <a:srgbClr val="173754"/>
+                  <a:srgbClr val="1F497D"/>
                 </a:solidFill>
               </a:defRPr>
             </a:pPr>
@@ -20296,7 +20296,7 @@
             <a:pPr>
               <a:defRPr sz="1450" cap="none">
                 <a:solidFill>
-                  <a:srgbClr val="172B3A"/>
+                  <a:srgbClr val="000000"/>
                 </a:solidFill>
               </a:defRPr>
             </a:pPr>
@@ -20339,7 +20339,7 @@
             <a:pPr>
               <a:defRPr sz="1500" b="1" cap="none">
                 <a:solidFill>
-                  <a:srgbClr val="173754"/>
+                  <a:srgbClr val="1F497D"/>
                 </a:solidFill>
               </a:defRPr>
             </a:pPr>
@@ -20382,7 +20382,7 @@
             <a:pPr>
               <a:defRPr sz="1450" cap="none">
                 <a:solidFill>
-                  <a:srgbClr val="172B3A"/>
+                  <a:srgbClr val="000000"/>
                 </a:solidFill>
               </a:defRPr>
             </a:pPr>
@@ -20425,7 +20425,7 @@
             <a:pPr>
               <a:defRPr sz="1500" b="1" cap="none">
                 <a:solidFill>
-                  <a:srgbClr val="173754"/>
+                  <a:srgbClr val="1F497D"/>
                 </a:solidFill>
               </a:defRPr>
             </a:pPr>
@@ -20468,7 +20468,7 @@
             <a:pPr>
               <a:defRPr sz="1450" cap="none">
                 <a:solidFill>
-                  <a:srgbClr val="172B3A"/>
+                  <a:srgbClr val="000000"/>
                 </a:solidFill>
               </a:defRPr>
             </a:pPr>
@@ -20511,7 +20511,7 @@
             <a:pPr>
               <a:defRPr sz="1750" b="1" cap="none">
                 <a:solidFill>
-                  <a:srgbClr val="173754"/>
+                  <a:srgbClr val="1F497D"/>
                 </a:solidFill>
               </a:defRPr>
             </a:pPr>
@@ -20544,7 +20544,7 @@
           <a:noFill/>
           <a:ln w="12700" cap="flat" cmpd="sng" algn="ctr">
             <a:solidFill>
-              <a:srgbClr val="CFDDE6"/>
+              <a:srgbClr val="4F81BD"/>
             </a:solidFill>
             <a:prstDash val="solid"/>
             <a:headEnd type="none"/>
@@ -20586,7 +20586,7 @@
             <a:pPr>
               <a:defRPr cap="none">
                 <a:solidFill>
-                  <a:srgbClr val="172B3A"/>
+                  <a:srgbClr val="000000"/>
                 </a:solidFill>
               </a:defRPr>
             </a:pPr>
@@ -20633,7 +20633,7 @@
             <a:pPr>
               <a:defRPr cap="none">
                 <a:solidFill>
-                  <a:srgbClr val="172B3A"/>
+                  <a:srgbClr val="000000"/>
                 </a:solidFill>
               </a:defRPr>
             </a:pPr>
@@ -20680,7 +20680,7 @@
             <a:pPr>
               <a:defRPr cap="none">
                 <a:solidFill>
-                  <a:srgbClr val="172B3A"/>
+                  <a:srgbClr val="000000"/>
                 </a:solidFill>
               </a:defRPr>
             </a:pPr>
@@ -20727,7 +20727,7 @@
             <a:pPr>
               <a:defRPr cap="none">
                 <a:solidFill>
-                  <a:srgbClr val="172B3A"/>
+                  <a:srgbClr val="000000"/>
                 </a:solidFill>
               </a:defRPr>
             </a:pPr>
@@ -20774,7 +20774,7 @@
             <a:pPr>
               <a:defRPr cap="none">
                 <a:solidFill>
-                  <a:srgbClr val="172B3A"/>
+                  <a:srgbClr val="000000"/>
                 </a:solidFill>
               </a:defRPr>
             </a:pPr>
@@ -20811,7 +20811,7 @@
           <a:noFill/>
           <a:ln w="12700" cap="flat" cmpd="sng" algn="ctr">
             <a:solidFill>
-              <a:srgbClr val="CFDDE6"/>
+              <a:srgbClr val="4F81BD"/>
             </a:solidFill>
             <a:prstDash val="solid"/>
             <a:headEnd type="none"/>
@@ -20853,7 +20853,7 @@
             <a:pPr>
               <a:defRPr sz="1750" b="1" cap="none">
                 <a:solidFill>
-                  <a:srgbClr val="173754"/>
+                  <a:srgbClr val="1F497D"/>
                 </a:solidFill>
               </a:defRPr>
             </a:pPr>
@@ -20896,7 +20896,7 @@
             <a:pPr>
               <a:defRPr sz="1450" cap="none">
                 <a:solidFill>
-                  <a:srgbClr val="172B3A"/>
+                  <a:srgbClr val="000000"/>
                 </a:solidFill>
               </a:defRPr>
             </a:pPr>
@@ -20929,11 +20929,11 @@
             </a:avLst>
           </a:prstGeom>
           <a:solidFill>
-            <a:srgbClr val="EEF5F9"/>
+            <a:srgbClr val="DCE6F2"/>
           </a:solidFill>
           <a:ln w="12700" cap="flat" cmpd="sng" algn="ctr">
             <a:solidFill>
-              <a:srgbClr val="CFDDE6"/>
+              <a:srgbClr val="4F81BD"/>
             </a:solidFill>
             <a:prstDash val="solid"/>
             <a:headEnd type="none"/>
@@ -20975,7 +20975,7 @@
             <a:pPr>
               <a:defRPr b="1" cap="none">
                 <a:solidFill>
-                  <a:srgbClr val="173754"/>
+                  <a:srgbClr val="1F497D"/>
                 </a:solidFill>
               </a:defRPr>
             </a:pPr>
@@ -21018,7 +21018,7 @@
             <a:pPr>
               <a:defRPr sz="1200" cap="none">
                 <a:solidFill>
-                  <a:srgbClr val="506473"/>
+                  <a:srgbClr val="808080"/>
                 </a:solidFill>
               </a:defRPr>
             </a:pPr>
@@ -21055,7 +21055,7 @@
           </a:solidFill>
           <a:ln w="12700" cap="flat" cmpd="sng" algn="ctr">
             <a:solidFill>
-              <a:srgbClr val="CFDDE6"/>
+              <a:srgbClr val="4F81BD"/>
             </a:solidFill>
             <a:prstDash val="solid"/>
             <a:headEnd type="none"/>
@@ -21097,7 +21097,7 @@
             <a:pPr>
               <a:defRPr b="1" cap="none">
                 <a:solidFill>
-                  <a:srgbClr val="173754"/>
+                  <a:srgbClr val="1F497D"/>
                 </a:solidFill>
               </a:defRPr>
             </a:pPr>
@@ -21140,7 +21140,7 @@
             <a:pPr>
               <a:defRPr sz="1200" cap="none">
                 <a:solidFill>
-                  <a:srgbClr val="506473"/>
+                  <a:srgbClr val="808080"/>
                 </a:solidFill>
               </a:defRPr>
             </a:pPr>
@@ -21211,7 +21211,7 @@
                       <a:noFill/>
                     </a:lnBlToTr>
                     <a:solidFill>
-                      <a:srgbClr val="173754"/>
+                      <a:srgbClr val="1F497D"/>
                     </a:solidFill>
                   </a:tcPr>
                 </a:tc>
@@ -21253,7 +21253,7 @@
                       <a:noFill/>
                     </a:lnBlToTr>
                     <a:solidFill>
-                      <a:srgbClr val="173754"/>
+                      <a:srgbClr val="1F497D"/>
                     </a:solidFill>
                   </a:tcPr>
                 </a:tc>
@@ -21275,7 +21275,7 @@
                       <a:r>
                         <a:rPr sz="1300" cap="none">
                           <a:solidFill>
-                            <a:srgbClr val="172B3A"/>
+                            <a:srgbClr val="000000"/>
                           </a:solidFill>
                         </a:rPr>
                         <a:t>Key Control</a:t>
@@ -21302,7 +21302,7 @@
                       <a:noFill/>
                     </a:lnBlToTr>
                     <a:solidFill>
-                      <a:srgbClr val="F2F7FA"/>
+                      <a:srgbClr val="DCE6F2"/>
                     </a:solidFill>
                   </a:tcPr>
                 </a:tc>
@@ -21317,7 +21317,7 @@
                       <a:r>
                         <a:rPr sz="1300" cap="none">
                           <a:solidFill>
-                            <a:srgbClr val="172B3A"/>
+                            <a:srgbClr val="000000"/>
                           </a:solidFill>
                         </a:rPr>
                         <a:t>ASSERT · VERIFIED: persona-bound signature</a:t>
@@ -21344,7 +21344,7 @@
                       <a:noFill/>
                     </a:lnBlToTr>
                     <a:solidFill>
-                      <a:srgbClr val="F2F7FA"/>
+                      <a:srgbClr val="DCE6F2"/>
                     </a:solidFill>
                   </a:tcPr>
                 </a:tc>
@@ -21366,7 +21366,7 @@
                       <a:r>
                         <a:rPr sz="1300" cap="none">
                           <a:solidFill>
-                            <a:srgbClr val="172B3A"/>
+                            <a:srgbClr val="000000"/>
                           </a:solidFill>
                         </a:rPr>
                         <a:t>Wallet Control</a:t>
@@ -21408,7 +21408,7 @@
                       <a:r>
                         <a:rPr sz="1300" cap="none">
                           <a:solidFill>
-                            <a:srgbClr val="172B3A"/>
+                            <a:srgbClr val="000000"/>
                           </a:solidFill>
                         </a:rPr>
                         <a:t>not tested</a:t>
@@ -21457,7 +21457,7 @@
                       <a:r>
                         <a:rPr sz="1300" cap="none">
                           <a:solidFill>
-                            <a:srgbClr val="172B3A"/>
+                            <a:srgbClr val="000000"/>
                           </a:solidFill>
                         </a:rPr>
                         <a:t>Persona Link</a:t>
@@ -21499,7 +21499,7 @@
                       <a:r>
                         <a:rPr sz="1300" cap="none">
                           <a:solidFill>
-                            <a:srgbClr val="172B3A"/>
+                            <a:srgbClr val="000000"/>
                           </a:solidFill>
                         </a:rPr>
                         <a:t>not tested</a:t>
@@ -21548,7 +21548,7 @@
                       <a:r>
                         <a:rPr sz="1300" cap="none">
                           <a:solidFill>
-                            <a:srgbClr val="172B3A"/>
+                            <a:srgbClr val="000000"/>
                           </a:solidFill>
                         </a:rPr>
                         <a:t>Same Operator</a:t>
@@ -21575,7 +21575,7 @@
                       <a:noFill/>
                     </a:lnBlToTr>
                     <a:solidFill>
-                      <a:srgbClr val="F2F7FA"/>
+                      <a:srgbClr val="DCE6F2"/>
                     </a:solidFill>
                   </a:tcPr>
                 </a:tc>
@@ -21590,7 +21590,7 @@
                       <a:r>
                         <a:rPr sz="1300" cap="none">
                           <a:solidFill>
-                            <a:srgbClr val="172B3A"/>
+                            <a:srgbClr val="000000"/>
                           </a:solidFill>
                         </a:rPr>
                         <a:t>HOLD · QUESTIONABLE: behavioural break</a:t>
@@ -21617,7 +21617,7 @@
                       <a:noFill/>
                     </a:lnBlToTr>
                     <a:solidFill>
-                      <a:srgbClr val="F2F7FA"/>
+                      <a:srgbClr val="DCE6F2"/>
                     </a:solidFill>
                   </a:tcPr>
                 </a:tc>
@@ -21707,14 +21707,14 @@
             <a:pPr>
               <a:defRPr cap="none">
                 <a:solidFill>
-                  <a:srgbClr val="172B3A"/>
+                  <a:srgbClr val="000000"/>
                 </a:solidFill>
               </a:defRPr>
             </a:pPr>
             <a:r>
               <a:rPr cap="none">
                 <a:solidFill>
-                  <a:srgbClr val="172B3A"/>
+                  <a:srgbClr val="000000"/>
                 </a:solidFill>
               </a:rPr>
               <a:t>Next: request out-of-band continuity proof and review activity after 14 March.</a:t>
@@ -21806,7 +21806,7 @@
             </a:pPr>
             <a:endParaRPr sz="1800" cap="none">
               <a:solidFill>
-                <a:srgbClr val="953734"/>
+                <a:srgbClr val="C0504D"/>
               </a:solidFill>
               <a:latin typeface="Calibri" pitchFamily="2" charset="0"/>
               <a:ea typeface="Calibri" pitchFamily="2" charset="0"/>
@@ -22164,7 +22164,7 @@
             <a:pPr>
               <a:defRPr sz="1750" b="1" cap="none">
                 <a:solidFill>
-                  <a:srgbClr val="173754"/>
+                  <a:srgbClr val="1F497D"/>
                 </a:solidFill>
               </a:defRPr>
             </a:pPr>
@@ -22207,7 +22207,7 @@
             <a:pPr>
               <a:defRPr sz="1300" cap="none">
                 <a:solidFill>
-                  <a:srgbClr val="172B3A"/>
+                  <a:srgbClr val="000000"/>
                 </a:solidFill>
               </a:defRPr>
             </a:pPr>
@@ -22250,7 +22250,7 @@
             <a:pPr>
               <a:defRPr b="1" cap="none">
                 <a:solidFill>
-                  <a:srgbClr val="173754"/>
+                  <a:srgbClr val="1F497D"/>
                 </a:solidFill>
               </a:defRPr>
             </a:pPr>
@@ -22293,7 +22293,7 @@
             <a:pPr>
               <a:defRPr sz="1250" cap="none">
                 <a:solidFill>
-                  <a:srgbClr val="172B3A"/>
+                  <a:srgbClr val="000000"/>
                 </a:solidFill>
               </a:defRPr>
             </a:pPr>
@@ -22336,7 +22336,7 @@
             <a:pPr>
               <a:defRPr sz="1100" cap="none">
                 <a:solidFill>
-                  <a:srgbClr val="0073B9"/>
+                  <a:srgbClr val="0070C0"/>
                 </a:solidFill>
               </a:defRPr>
             </a:pPr>
@@ -22379,7 +22379,7 @@
             <a:pPr>
               <a:defRPr b="1" cap="none">
                 <a:solidFill>
-                  <a:srgbClr val="173754"/>
+                  <a:srgbClr val="1F497D"/>
                 </a:solidFill>
               </a:defRPr>
             </a:pPr>
@@ -22422,7 +22422,7 @@
             <a:pPr>
               <a:defRPr sz="1250" cap="none">
                 <a:solidFill>
-                  <a:srgbClr val="172B3A"/>
+                  <a:srgbClr val="000000"/>
                 </a:solidFill>
               </a:defRPr>
             </a:pPr>
@@ -22465,7 +22465,7 @@
             <a:pPr>
               <a:defRPr sz="1100" cap="none">
                 <a:solidFill>
-                  <a:srgbClr val="0073B9"/>
+                  <a:srgbClr val="0070C0"/>
                 </a:solidFill>
               </a:defRPr>
             </a:pPr>
@@ -22508,7 +22508,7 @@
             <a:pPr>
               <a:defRPr b="1" cap="none">
                 <a:solidFill>
-                  <a:srgbClr val="173754"/>
+                  <a:srgbClr val="1F497D"/>
                 </a:solidFill>
               </a:defRPr>
             </a:pPr>
@@ -22551,7 +22551,7 @@
             <a:pPr>
               <a:defRPr sz="1250" cap="none">
                 <a:solidFill>
-                  <a:srgbClr val="172B3A"/>
+                  <a:srgbClr val="000000"/>
                 </a:solidFill>
               </a:defRPr>
             </a:pPr>
@@ -22594,7 +22594,7 @@
             <a:pPr>
               <a:defRPr sz="1100" cap="none">
                 <a:solidFill>
-                  <a:srgbClr val="0073B9"/>
+                  <a:srgbClr val="0070C0"/>
                 </a:solidFill>
               </a:defRPr>
             </a:pPr>
@@ -22637,7 +22637,7 @@
             <a:pPr>
               <a:defRPr b="1" cap="none">
                 <a:solidFill>
-                  <a:srgbClr val="173754"/>
+                  <a:srgbClr val="1F497D"/>
                 </a:solidFill>
               </a:defRPr>
             </a:pPr>
@@ -22680,7 +22680,7 @@
             <a:pPr>
               <a:defRPr sz="1250" cap="none">
                 <a:solidFill>
-                  <a:srgbClr val="172B3A"/>
+                  <a:srgbClr val="000000"/>
                 </a:solidFill>
               </a:defRPr>
             </a:pPr>
@@ -22723,7 +22723,7 @@
             <a:pPr>
               <a:defRPr sz="1100" cap="none">
                 <a:solidFill>
-                  <a:srgbClr val="0073B9"/>
+                  <a:srgbClr val="0070C0"/>
                 </a:solidFill>
               </a:defRPr>
             </a:pPr>
@@ -22756,7 +22756,7 @@
           <a:noFill/>
           <a:ln w="12700" cap="flat" cmpd="sng" algn="ctr">
             <a:solidFill>
-              <a:srgbClr val="CFDDE6"/>
+              <a:srgbClr val="4F81BD"/>
             </a:solidFill>
             <a:prstDash val="solid"/>
             <a:headEnd type="none"/>
@@ -22798,7 +22798,7 @@
             <a:pPr>
               <a:defRPr sz="1750" b="1" cap="none">
                 <a:solidFill>
-                  <a:srgbClr val="0073B9"/>
+                  <a:srgbClr val="0070C0"/>
                 </a:solidFill>
               </a:defRPr>
             </a:pPr>
@@ -22841,7 +22841,7 @@
             <a:pPr>
               <a:defRPr sz="1550" b="1" cap="none">
                 <a:solidFill>
-                  <a:srgbClr val="173754"/>
+                  <a:srgbClr val="1F497D"/>
                 </a:solidFill>
               </a:defRPr>
             </a:pPr>
@@ -22884,7 +22884,7 @@
             <a:pPr>
               <a:defRPr cap="none">
                 <a:solidFill>
-                  <a:srgbClr val="172B3A"/>
+                  <a:srgbClr val="000000"/>
                 </a:solidFill>
               </a:defRPr>
             </a:pPr>
@@ -22927,7 +22927,7 @@
             <a:pPr>
               <a:defRPr sz="1550" b="1" cap="none">
                 <a:solidFill>
-                  <a:srgbClr val="173754"/>
+                  <a:srgbClr val="1F497D"/>
                 </a:solidFill>
               </a:defRPr>
             </a:pPr>
@@ -22970,7 +22970,7 @@
             <a:pPr>
               <a:defRPr cap="none">
                 <a:solidFill>
-                  <a:srgbClr val="172B3A"/>
+                  <a:srgbClr val="000000"/>
                 </a:solidFill>
               </a:defRPr>
             </a:pPr>
@@ -23013,7 +23013,7 @@
             <a:pPr>
               <a:defRPr sz="1550" b="1" cap="none">
                 <a:solidFill>
-                  <a:srgbClr val="173754"/>
+                  <a:srgbClr val="1F497D"/>
                 </a:solidFill>
               </a:defRPr>
             </a:pPr>
@@ -23056,7 +23056,7 @@
             <a:pPr>
               <a:defRPr cap="none">
                 <a:solidFill>
-                  <a:srgbClr val="172B3A"/>
+                  <a:srgbClr val="000000"/>
                 </a:solidFill>
               </a:defRPr>
             </a:pPr>
@@ -23099,7 +23099,7 @@
             <a:pPr>
               <a:defRPr sz="1550" b="1" cap="none">
                 <a:solidFill>
-                  <a:srgbClr val="173754"/>
+                  <a:srgbClr val="1F497D"/>
                 </a:solidFill>
               </a:defRPr>
             </a:pPr>
@@ -23142,7 +23142,7 @@
             <a:pPr>
               <a:defRPr cap="none">
                 <a:solidFill>
-                  <a:srgbClr val="172B3A"/>
+                  <a:srgbClr val="000000"/>
                 </a:solidFill>
               </a:defRPr>
             </a:pPr>
@@ -23185,7 +23185,7 @@
             <a:pPr>
               <a:defRPr sz="1550" b="1" cap="none">
                 <a:solidFill>
-                  <a:srgbClr val="173754"/>
+                  <a:srgbClr val="1F497D"/>
                 </a:solidFill>
               </a:defRPr>
             </a:pPr>
@@ -23228,14 +23228,14 @@
             <a:pPr>
               <a:defRPr cap="none" sz="1250">
                 <a:solidFill>
-                  <a:srgbClr val="172B3A"/>
+                  <a:srgbClr val="000000"/>
                 </a:solidFill>
               </a:defRPr>
             </a:pPr>
             <a:r>
               <a:rPr cap="none" sz="1250">
                 <a:solidFill>
-                  <a:srgbClr val="172B3A"/>
+                  <a:srgbClr val="000000"/>
                 </a:solidFill>
               </a:rPr>
               <a:t>Benchmark: copied keys, replay, clones, takeovers, account sales. Prototype scenarios add wallet ladder and sock-puppet vouch rings.</a:t>
@@ -23276,7 +23276,7 @@
             <a:pPr>
               <a:defRPr sz="1600" b="1" cap="none">
                 <a:solidFill>
-                  <a:srgbClr val="173754"/>
+                  <a:srgbClr val="1F497D"/>
                 </a:solidFill>
               </a:defRPr>
             </a:pPr>
@@ -23319,7 +23319,7 @@
             <a:pPr>
               <a:defRPr sz="1300" cap="none">
                 <a:solidFill>
-                  <a:srgbClr val="172B3A"/>
+                  <a:srgbClr val="000000"/>
                 </a:solidFill>
               </a:defRPr>
             </a:pPr>
@@ -23365,7 +23365,7 @@
             <a:pPr>
               <a:defRPr sz="900" b="1">
                 <a:solidFill>
-                  <a:srgbClr val="173754"/>
+                  <a:srgbClr val="1F497D"/>
                 </a:solidFill>
                 <a:latin typeface="Arial"/>
                 <a:ea typeface="Arial"/>
@@ -23375,7 +23375,7 @@
             <a:r>
               <a:rPr sz="900" b="1">
                 <a:solidFill>
-                  <a:srgbClr val="173754"/>
+                  <a:srgbClr val="1F497D"/>
                 </a:solidFill>
                 <a:latin typeface="Arial"/>
                 <a:ea typeface="Arial"/>
@@ -23422,7 +23422,7 @@
             <a:pPr>
               <a:defRPr sz="863" b="0">
                 <a:solidFill>
-                  <a:srgbClr val="506473"/>
+                  <a:srgbClr val="808080"/>
                 </a:solidFill>
                 <a:latin typeface="Arial"/>
                 <a:ea typeface="Arial"/>
@@ -23432,7 +23432,7 @@
             <a:r>
               <a:rPr sz="863" b="0">
                 <a:solidFill>
-                  <a:srgbClr val="506473"/>
+                  <a:srgbClr val="808080"/>
                 </a:solidFill>
                 <a:latin typeface="Arial"/>
                 <a:ea typeface="Arial"/>

</xml_diff>